<commit_message>
Update user manual PowerPoint
Co-Authored-By: Claude Sonnet 4.6 <noreply@anthropic.com>
</commit_message>
<xml_diff>
--- a/AFCAC_RAST_Dashboard_User_Manual.pptx
+++ b/AFCAC_RAST_Dashboard_User_Manual.pptx
@@ -2130,45 +2130,105 @@
           </a:p>
         </p:txBody>
       </p:sp>
-      <p:pic>
-        <p:nvPicPr>
-          <p:cNvPr id="15" name="Image 39">
+      <p:grpSp>
+        <p:nvGrpSpPr>
+          <p:cNvPr id="17" name="Group 16">
             <a:extLst>
               <a:ext uri="{FF2B5EF4-FFF2-40B4-BE49-F238E27FC236}">
-                <a16:creationId xmlns:a16="http://schemas.microsoft.com/office/drawing/2014/main" id="{5DBBA1D9-A5AD-317A-617D-9C35F4EAB33B}"/>
+                <a16:creationId xmlns:a16="http://schemas.microsoft.com/office/drawing/2014/main" id="{65CC0273-59F7-F0D1-49C9-5DB0EFF785C1}"/>
               </a:ext>
             </a:extLst>
           </p:cNvPr>
-          <p:cNvPicPr>
-            <a:picLocks noChangeAspect="1"/>
-          </p:cNvPicPr>
-          <p:nvPr/>
-        </p:nvPicPr>
-        <p:blipFill rotWithShape="1">
-          <a:blip r:embed="rId3" cstate="print">
-            <a:extLst>
-              <a:ext uri="{28A0092B-C50C-407E-A947-70E740481C1C}">
-                <a14:useLocalDpi xmlns:a14="http://schemas.microsoft.com/office/drawing/2010/main" val="0"/>
-              </a:ext>
-            </a:extLst>
-          </a:blip>
-          <a:srcRect t="398"/>
-          <a:stretch/>
-        </p:blipFill>
-        <p:spPr bwMode="auto">
-          <a:xfrm rot="16200000" flipH="1">
-            <a:off x="3256840" y="-3092248"/>
-            <a:ext cx="184760" cy="6369256"/>
-          </a:xfrm>
-          <a:prstGeom prst="rect">
-            <a:avLst/>
-          </a:prstGeom>
-          <a:noFill/>
-          <a:ln>
+          <p:cNvGrpSpPr/>
+          <p:nvPr/>
+        </p:nvGrpSpPr>
+        <p:grpSpPr>
+          <a:xfrm>
+            <a:off x="164592" y="-6483"/>
+            <a:ext cx="12027408" cy="191243"/>
+            <a:chOff x="164592" y="-6483"/>
+            <a:chExt cx="12027408" cy="191243"/>
+          </a:xfrm>
+        </p:grpSpPr>
+        <p:pic>
+          <p:nvPicPr>
+            <p:cNvPr id="15" name="Image 39">
+              <a:extLst>
+                <a:ext uri="{FF2B5EF4-FFF2-40B4-BE49-F238E27FC236}">
+                  <a16:creationId xmlns:a16="http://schemas.microsoft.com/office/drawing/2014/main" id="{5DBBA1D9-A5AD-317A-617D-9C35F4EAB33B}"/>
+                </a:ext>
+              </a:extLst>
+            </p:cNvPr>
+            <p:cNvPicPr>
+              <a:picLocks noChangeAspect="1"/>
+            </p:cNvPicPr>
+            <p:nvPr/>
+          </p:nvPicPr>
+          <p:blipFill rotWithShape="1">
+            <a:blip r:embed="rId3" cstate="print">
+              <a:extLst>
+                <a:ext uri="{28A0092B-C50C-407E-A947-70E740481C1C}">
+                  <a14:useLocalDpi xmlns:a14="http://schemas.microsoft.com/office/drawing/2010/main" val="0"/>
+                </a:ext>
+              </a:extLst>
+            </a:blip>
+            <a:srcRect t="398"/>
+            <a:stretch/>
+          </p:blipFill>
+          <p:spPr bwMode="auto">
+            <a:xfrm rot="16200000" flipH="1">
+              <a:off x="3256840" y="-3092248"/>
+              <a:ext cx="184760" cy="6369256"/>
+            </a:xfrm>
+            <a:prstGeom prst="rect">
+              <a:avLst/>
+            </a:prstGeom>
             <a:noFill/>
-          </a:ln>
-        </p:spPr>
-      </p:pic>
+            <a:ln>
+              <a:noFill/>
+            </a:ln>
+          </p:spPr>
+        </p:pic>
+        <p:pic>
+          <p:nvPicPr>
+            <p:cNvPr id="16" name="Image 39">
+              <a:extLst>
+                <a:ext uri="{FF2B5EF4-FFF2-40B4-BE49-F238E27FC236}">
+                  <a16:creationId xmlns:a16="http://schemas.microsoft.com/office/drawing/2014/main" id="{1D2C27F5-D017-3F28-CA26-EA3ED4E0DED1}"/>
+                </a:ext>
+              </a:extLst>
+            </p:cNvPr>
+            <p:cNvPicPr>
+              <a:picLocks noChangeAspect="1"/>
+            </p:cNvPicPr>
+            <p:nvPr/>
+          </p:nvPicPr>
+          <p:blipFill rotWithShape="1">
+            <a:blip r:embed="rId3" cstate="print">
+              <a:extLst>
+                <a:ext uri="{28A0092B-C50C-407E-A947-70E740481C1C}">
+                  <a14:useLocalDpi xmlns:a14="http://schemas.microsoft.com/office/drawing/2010/main" val="0"/>
+                </a:ext>
+              </a:extLst>
+            </a:blip>
+            <a:srcRect t="398"/>
+            <a:stretch/>
+          </p:blipFill>
+          <p:spPr bwMode="auto">
+            <a:xfrm rot="16200000" flipH="1">
+              <a:off x="8914992" y="-3098731"/>
+              <a:ext cx="184760" cy="6369256"/>
+            </a:xfrm>
+            <a:prstGeom prst="rect">
+              <a:avLst/>
+            </a:prstGeom>
+            <a:noFill/>
+            <a:ln>
+              <a:noFill/>
+            </a:ln>
+          </p:spPr>
+        </p:pic>
+      </p:grpSp>
     </p:spTree>
   </p:cSld>
   <p:clrMapOvr>
@@ -2217,7 +2277,7 @@
             <a:avLst/>
           </a:prstGeom>
           <a:solidFill>
-            <a:srgbClr val="1B3A2D"/>
+            <a:srgbClr val="145847"/>
           </a:solidFill>
           <a:ln/>
         </p:spPr>
@@ -2415,7 +2475,7 @@
             <a:avLst/>
           </a:prstGeom>
           <a:solidFill>
-            <a:srgbClr val="1B3A2D"/>
+            <a:srgbClr val="145847"/>
           </a:solidFill>
           <a:ln/>
         </p:spPr>
@@ -3072,7 +3132,7 @@
             <a:avLst/>
           </a:prstGeom>
           <a:solidFill>
-            <a:srgbClr val="1B3A2D"/>
+            <a:srgbClr val="145847"/>
           </a:solidFill>
           <a:ln/>
         </p:spPr>
@@ -3636,7 +3696,7 @@
             <a:avLst/>
           </a:prstGeom>
           <a:solidFill>
-            <a:srgbClr val="1B3A2D"/>
+            <a:srgbClr val="145847"/>
           </a:solidFill>
           <a:ln/>
         </p:spPr>
@@ -3798,7 +3858,7 @@
             <a:avLst/>
           </a:prstGeom>
           <a:solidFill>
-            <a:srgbClr val="1B3A2D"/>
+            <a:srgbClr val="145847"/>
           </a:solidFill>
           <a:ln/>
         </p:spPr>
@@ -3861,7 +3921,7 @@
             <a:avLst/>
           </a:prstGeom>
           <a:solidFill>
-            <a:srgbClr val="1B3A2D"/>
+            <a:srgbClr val="145847"/>
           </a:solidFill>
           <a:ln/>
         </p:spPr>
@@ -4028,7 +4088,7 @@
             <a:avLst/>
           </a:prstGeom>
           <a:solidFill>
-            <a:srgbClr val="1B3A2D"/>
+            <a:srgbClr val="145847"/>
           </a:solidFill>
           <a:ln/>
         </p:spPr>
@@ -4416,7 +4476,7 @@
             <a:avLst/>
           </a:prstGeom>
           <a:solidFill>
-            <a:srgbClr val="1B3A2D"/>
+            <a:srgbClr val="145847"/>
           </a:solidFill>
           <a:ln/>
         </p:spPr>
@@ -4578,7 +4638,7 @@
             <a:avLst/>
           </a:prstGeom>
           <a:solidFill>
-            <a:srgbClr val="1B3A2D"/>
+            <a:srgbClr val="145847"/>
           </a:solidFill>
           <a:ln/>
         </p:spPr>
@@ -5397,7 +5457,7 @@
             <a:avLst/>
           </a:prstGeom>
           <a:solidFill>
-            <a:srgbClr val="1B3A2D"/>
+            <a:srgbClr val="145847"/>
           </a:solidFill>
           <a:ln/>
         </p:spPr>
@@ -5459,7 +5519,7 @@
     <p:bg>
       <p:bgPr>
         <a:solidFill>
-          <a:srgbClr val="1B3A2D"/>
+          <a:srgbClr val="145847"/>
         </a:solidFill>
         <a:effectLst/>
       </p:bgPr>
@@ -5493,7 +5553,7 @@
             <a:avLst/>
           </a:prstGeom>
           <a:solidFill>
-            <a:srgbClr val="C9A84C"/>
+            <a:srgbClr val="B3AE41"/>
           </a:solidFill>
           <a:ln/>
         </p:spPr>
@@ -5520,7 +5580,7 @@
             <a:avLst/>
           </a:prstGeom>
           <a:solidFill>
-            <a:srgbClr val="C9A84C"/>
+            <a:srgbClr val="B3AE41"/>
           </a:solidFill>
           <a:ln/>
         </p:spPr>
@@ -5559,12 +5619,11 @@
             <a:r>
               <a:rPr lang="en-US" sz="9600" dirty="0">
                 <a:solidFill>
-                  <a:srgbClr val="C9A84C"/>
+                  <a:srgbClr val="B3AE41"/>
                 </a:solidFill>
               </a:rPr>
               <a:t>✈</a:t>
             </a:r>
-            <a:endParaRPr lang="en-US" sz="9600" dirty="0"/>
           </a:p>
         </p:txBody>
       </p:sp>
@@ -5595,14 +5654,14 @@
             <a:r>
               <a:rPr lang="en-US" sz="4200" b="1" dirty="0">
                 <a:solidFill>
-                  <a:srgbClr val="ABB616"/>
+                  <a:srgbClr val="B3AE41"/>
                 </a:solidFill>
               </a:rPr>
               <a:t>AFCAC</a:t>
             </a:r>
             <a:endParaRPr lang="en-US" sz="4200" dirty="0">
               <a:solidFill>
-                <a:srgbClr val="ABB616"/>
+                <a:srgbClr val="B3AE41"/>
               </a:solidFill>
             </a:endParaRPr>
           </a:p>
@@ -7829,6 +7888,84 @@
           </a:p>
         </p:txBody>
       </p:sp>
+      <p:pic>
+        <p:nvPicPr>
+          <p:cNvPr id="61" name="Image 39">
+            <a:extLst>
+              <a:ext uri="{FF2B5EF4-FFF2-40B4-BE49-F238E27FC236}">
+                <a16:creationId xmlns:a16="http://schemas.microsoft.com/office/drawing/2014/main" id="{53DE72C1-4DD3-8699-7351-780D07812EAB}"/>
+              </a:ext>
+            </a:extLst>
+          </p:cNvPr>
+          <p:cNvPicPr>
+            <a:picLocks noChangeAspect="1"/>
+          </p:cNvPicPr>
+          <p:nvPr/>
+        </p:nvPicPr>
+        <p:blipFill rotWithShape="1">
+          <a:blip r:embed="rId3" cstate="print">
+            <a:extLst>
+              <a:ext uri="{28A0092B-C50C-407E-A947-70E740481C1C}">
+                <a14:useLocalDpi xmlns:a14="http://schemas.microsoft.com/office/drawing/2010/main" val="0"/>
+              </a:ext>
+            </a:extLst>
+          </a:blip>
+          <a:srcRect t="398"/>
+          <a:stretch/>
+        </p:blipFill>
+        <p:spPr bwMode="auto">
+          <a:xfrm rot="16200000" flipH="1">
+            <a:off x="3083618" y="-3082954"/>
+            <a:ext cx="184760" cy="6369256"/>
+          </a:xfrm>
+          <a:prstGeom prst="rect">
+            <a:avLst/>
+          </a:prstGeom>
+          <a:noFill/>
+          <a:ln>
+            <a:noFill/>
+          </a:ln>
+        </p:spPr>
+      </p:pic>
+      <p:pic>
+        <p:nvPicPr>
+          <p:cNvPr id="62" name="Image 39">
+            <a:extLst>
+              <a:ext uri="{FF2B5EF4-FFF2-40B4-BE49-F238E27FC236}">
+                <a16:creationId xmlns:a16="http://schemas.microsoft.com/office/drawing/2014/main" id="{142A31A2-416C-E1B6-66C1-4CA95737D32F}"/>
+              </a:ext>
+            </a:extLst>
+          </p:cNvPr>
+          <p:cNvPicPr>
+            <a:picLocks noChangeAspect="1"/>
+          </p:cNvPicPr>
+          <p:nvPr/>
+        </p:nvPicPr>
+        <p:blipFill rotWithShape="1">
+          <a:blip r:embed="rId3" cstate="print">
+            <a:extLst>
+              <a:ext uri="{28A0092B-C50C-407E-A947-70E740481C1C}">
+                <a14:useLocalDpi xmlns:a14="http://schemas.microsoft.com/office/drawing/2010/main" val="0"/>
+              </a:ext>
+            </a:extLst>
+          </a:blip>
+          <a:srcRect t="398"/>
+          <a:stretch/>
+        </p:blipFill>
+        <p:spPr bwMode="auto">
+          <a:xfrm rot="16200000" flipH="1">
+            <a:off x="8914300" y="-3080811"/>
+            <a:ext cx="184760" cy="6369256"/>
+          </a:xfrm>
+          <a:prstGeom prst="rect">
+            <a:avLst/>
+          </a:prstGeom>
+          <a:noFill/>
+          <a:ln>
+            <a:noFill/>
+          </a:ln>
+        </p:spPr>
+      </p:pic>
     </p:spTree>
   </p:cSld>
   <p:clrMapOvr>
@@ -8831,7 +8968,7 @@
             <a:avLst/>
           </a:prstGeom>
           <a:solidFill>
-            <a:srgbClr val="1B3A2D"/>
+            <a:srgbClr val="145847"/>
           </a:solidFill>
           <a:ln/>
         </p:spPr>
@@ -9029,7 +9166,7 @@
             <a:avLst/>
           </a:prstGeom>
           <a:solidFill>
-            <a:srgbClr val="1B3A2D"/>
+            <a:srgbClr val="145847"/>
           </a:solidFill>
           <a:ln/>
         </p:spPr>
@@ -9092,7 +9229,7 @@
             <a:avLst/>
           </a:prstGeom>
           <a:solidFill>
-            <a:srgbClr val="1B3A2D"/>
+            <a:srgbClr val="145847"/>
           </a:solidFill>
           <a:ln/>
         </p:spPr>
@@ -9335,7 +9472,7 @@
             <a:avLst/>
           </a:prstGeom>
           <a:solidFill>
-            <a:srgbClr val="1B3A2D"/>
+            <a:srgbClr val="145847"/>
           </a:solidFill>
           <a:ln/>
         </p:spPr>
@@ -9650,7 +9787,7 @@
             <a:avLst/>
           </a:prstGeom>
           <a:solidFill>
-            <a:srgbClr val="1B3A2D"/>
+            <a:srgbClr val="145847"/>
           </a:solidFill>
           <a:ln/>
         </p:spPr>
@@ -9783,7 +9920,7 @@
             <a:avLst/>
           </a:prstGeom>
           <a:solidFill>
-            <a:srgbClr val="C9A84C"/>
+            <a:srgbClr val="B3AE41"/>
           </a:solidFill>
           <a:ln/>
         </p:spPr>
@@ -9943,7 +10080,7 @@
             <a:avLst/>
           </a:prstGeom>
           <a:solidFill>
-            <a:srgbClr val="1B3A2D"/>
+            <a:srgbClr val="145847"/>
           </a:solidFill>
           <a:ln/>
         </p:spPr>
@@ -10141,7 +10278,7 @@
             <a:avLst/>
           </a:prstGeom>
           <a:solidFill>
-            <a:srgbClr val="1B3A2D"/>
+            <a:srgbClr val="145847"/>
           </a:solidFill>
           <a:ln/>
         </p:spPr>
@@ -10993,7 +11130,7 @@
             <a:avLst/>
           </a:prstGeom>
           <a:solidFill>
-            <a:srgbClr val="1B3A2D"/>
+            <a:srgbClr val="145847"/>
           </a:solidFill>
           <a:ln/>
         </p:spPr>
@@ -11191,7 +11328,7 @@
             <a:avLst/>
           </a:prstGeom>
           <a:solidFill>
-            <a:srgbClr val="1B3A2D"/>
+            <a:srgbClr val="145847"/>
           </a:solidFill>
           <a:ln/>
         </p:spPr>
@@ -11983,7 +12120,7 @@
             <a:avLst/>
           </a:prstGeom>
           <a:solidFill>
-            <a:srgbClr val="1B3A2D"/>
+            <a:srgbClr val="145847"/>
           </a:solidFill>
           <a:ln/>
         </p:spPr>
@@ -12394,7 +12531,7 @@
             <a:avLst/>
           </a:prstGeom>
           <a:solidFill>
-            <a:srgbClr val="1B3A2D"/>
+            <a:srgbClr val="145847"/>
           </a:solidFill>
           <a:ln/>
         </p:spPr>
@@ -12556,7 +12693,7 @@
             <a:avLst/>
           </a:prstGeom>
           <a:solidFill>
-            <a:srgbClr val="1B3A2D"/>
+            <a:srgbClr val="145847"/>
           </a:solidFill>
           <a:ln/>
         </p:spPr>
@@ -12619,7 +12756,7 @@
             <a:avLst/>
           </a:prstGeom>
           <a:solidFill>
-            <a:srgbClr val="1B3A2D"/>
+            <a:srgbClr val="145847"/>
           </a:solidFill>
           <a:ln/>
         </p:spPr>
@@ -12800,7 +12937,7 @@
             <a:avLst/>
           </a:prstGeom>
           <a:solidFill>
-            <a:srgbClr val="1B3A2D"/>
+            <a:srgbClr val="145847"/>
           </a:solidFill>
           <a:ln/>
         </p:spPr>
@@ -12967,7 +13104,7 @@
             <a:avLst/>
           </a:prstGeom>
           <a:solidFill>
-            <a:srgbClr val="1B3A2D"/>
+            <a:srgbClr val="145847"/>
           </a:solidFill>
           <a:ln/>
         </p:spPr>
@@ -13274,7 +13411,7 @@
             <a:avLst/>
           </a:prstGeom>
           <a:solidFill>
-            <a:srgbClr val="1B3A2D"/>
+            <a:srgbClr val="145847"/>
           </a:solidFill>
           <a:ln/>
         </p:spPr>
@@ -13472,7 +13609,7 @@
             <a:avLst/>
           </a:prstGeom>
           <a:solidFill>
-            <a:srgbClr val="1B3A2D"/>
+            <a:srgbClr val="145847"/>
           </a:solidFill>
           <a:ln/>
         </p:spPr>
@@ -13535,7 +13672,7 @@
             <a:avLst/>
           </a:prstGeom>
           <a:solidFill>
-            <a:srgbClr val="1B3A2D"/>
+            <a:srgbClr val="145847"/>
           </a:solidFill>
           <a:ln/>
         </p:spPr>
@@ -13702,7 +13839,7 @@
             <a:avLst/>
           </a:prstGeom>
           <a:solidFill>
-            <a:srgbClr val="1B3A2D"/>
+            <a:srgbClr val="145847"/>
           </a:solidFill>
           <a:ln/>
         </p:spPr>
@@ -14070,7 +14207,7 @@
             <a:avLst/>
           </a:prstGeom>
           <a:solidFill>
-            <a:srgbClr val="1B3A2D"/>
+            <a:srgbClr val="145847"/>
           </a:solidFill>
           <a:ln/>
         </p:spPr>
@@ -14268,7 +14405,7 @@
             <a:avLst/>
           </a:prstGeom>
           <a:solidFill>
-            <a:srgbClr val="1B3A2D"/>
+            <a:srgbClr val="145847"/>
           </a:solidFill>
           <a:ln/>
         </p:spPr>
@@ -14367,7 +14504,7 @@
             <a:avLst/>
           </a:prstGeom>
           <a:solidFill>
-            <a:srgbClr val="1B3A2D"/>
+            <a:srgbClr val="145847"/>
           </a:solidFill>
           <a:ln/>
         </p:spPr>
@@ -14494,7 +14631,7 @@
             <a:avLst/>
           </a:prstGeom>
           <a:solidFill>
-            <a:srgbClr val="1B3A2D"/>
+            <a:srgbClr val="145847"/>
           </a:solidFill>
           <a:ln/>
         </p:spPr>
@@ -14809,7 +14946,7 @@
             <a:avLst/>
           </a:prstGeom>
           <a:solidFill>
-            <a:srgbClr val="1B3A2D"/>
+            <a:srgbClr val="145847"/>
           </a:solidFill>
           <a:ln/>
         </p:spPr>

</xml_diff>

<commit_message>
Update user manual PowerPoint and add utility scripts
Co-Authored-By: Claude Sonnet 4.6 <noreply@anthropic.com>
</commit_message>
<xml_diff>
--- a/AFCAC_RAST_Dashboard_User_Manual.pptx
+++ b/AFCAC_RAST_Dashboard_User_Manual.pptx
@@ -3648,6 +3648,105 @@
           </a:p>
         </p:txBody>
       </p:sp>
+      <p:grpSp>
+        <p:nvGrpSpPr>
+          <p:cNvPr id="43" name="Group 42">
+            <a:extLst>
+              <a:ext uri="{FF2B5EF4-FFF2-40B4-BE49-F238E27FC236}">
+                <a16:creationId xmlns:a16="http://schemas.microsoft.com/office/drawing/2014/main" id="{71844FB1-AB10-0E34-0A90-98A5483FDEF5}"/>
+              </a:ext>
+            </a:extLst>
+          </p:cNvPr>
+          <p:cNvGrpSpPr/>
+          <p:nvPr/>
+        </p:nvGrpSpPr>
+        <p:grpSpPr>
+          <a:xfrm>
+            <a:off x="-8630" y="9294"/>
+            <a:ext cx="12199938" cy="186903"/>
+            <a:chOff x="-8630" y="9294"/>
+            <a:chExt cx="12199938" cy="186903"/>
+          </a:xfrm>
+        </p:grpSpPr>
+        <p:pic>
+          <p:nvPicPr>
+            <p:cNvPr id="44" name="Image 39">
+              <a:extLst>
+                <a:ext uri="{FF2B5EF4-FFF2-40B4-BE49-F238E27FC236}">
+                  <a16:creationId xmlns:a16="http://schemas.microsoft.com/office/drawing/2014/main" id="{8109C65B-B08D-F7C2-B817-8A67F074B4C5}"/>
+                </a:ext>
+              </a:extLst>
+            </p:cNvPr>
+            <p:cNvPicPr>
+              <a:picLocks noChangeAspect="1"/>
+            </p:cNvPicPr>
+            <p:nvPr/>
+          </p:nvPicPr>
+          <p:blipFill rotWithShape="1">
+            <a:blip r:embed="rId3" cstate="print">
+              <a:extLst>
+                <a:ext uri="{28A0092B-C50C-407E-A947-70E740481C1C}">
+                  <a14:useLocalDpi xmlns:a14="http://schemas.microsoft.com/office/drawing/2010/main" val="0"/>
+                </a:ext>
+              </a:extLst>
+            </a:blip>
+            <a:srcRect t="398"/>
+            <a:stretch/>
+          </p:blipFill>
+          <p:spPr bwMode="auto">
+            <a:xfrm rot="16200000" flipH="1">
+              <a:off x="3083618" y="-3082954"/>
+              <a:ext cx="184760" cy="6369256"/>
+            </a:xfrm>
+            <a:prstGeom prst="rect">
+              <a:avLst/>
+            </a:prstGeom>
+            <a:noFill/>
+            <a:ln>
+              <a:noFill/>
+            </a:ln>
+          </p:spPr>
+        </p:pic>
+        <p:pic>
+          <p:nvPicPr>
+            <p:cNvPr id="45" name="Image 39">
+              <a:extLst>
+                <a:ext uri="{FF2B5EF4-FFF2-40B4-BE49-F238E27FC236}">
+                  <a16:creationId xmlns:a16="http://schemas.microsoft.com/office/drawing/2014/main" id="{FC836CC2-A901-1D87-5D29-3A15EF40600C}"/>
+                </a:ext>
+              </a:extLst>
+            </p:cNvPr>
+            <p:cNvPicPr>
+              <a:picLocks noChangeAspect="1"/>
+            </p:cNvPicPr>
+            <p:nvPr/>
+          </p:nvPicPr>
+          <p:blipFill rotWithShape="1">
+            <a:blip r:embed="rId3" cstate="print">
+              <a:extLst>
+                <a:ext uri="{28A0092B-C50C-407E-A947-70E740481C1C}">
+                  <a14:useLocalDpi xmlns:a14="http://schemas.microsoft.com/office/drawing/2010/main" val="0"/>
+                </a:ext>
+              </a:extLst>
+            </a:blip>
+            <a:srcRect t="398"/>
+            <a:stretch/>
+          </p:blipFill>
+          <p:spPr bwMode="auto">
+            <a:xfrm rot="16200000" flipH="1">
+              <a:off x="8914300" y="-3080811"/>
+              <a:ext cx="184760" cy="6369256"/>
+            </a:xfrm>
+            <a:prstGeom prst="rect">
+              <a:avLst/>
+            </a:prstGeom>
+            <a:noFill/>
+            <a:ln>
+              <a:noFill/>
+            </a:ln>
+          </p:spPr>
+        </p:pic>
+      </p:grpSp>
     </p:spTree>
   </p:cSld>
   <p:clrMapOvr>
@@ -4428,6 +4527,105 @@
           </a:p>
         </p:txBody>
       </p:sp>
+      <p:grpSp>
+        <p:nvGrpSpPr>
+          <p:cNvPr id="19" name="Group 18">
+            <a:extLst>
+              <a:ext uri="{FF2B5EF4-FFF2-40B4-BE49-F238E27FC236}">
+                <a16:creationId xmlns:a16="http://schemas.microsoft.com/office/drawing/2014/main" id="{27DEE2B2-8119-2177-4D4C-1D5976BDA896}"/>
+              </a:ext>
+            </a:extLst>
+          </p:cNvPr>
+          <p:cNvGrpSpPr/>
+          <p:nvPr/>
+        </p:nvGrpSpPr>
+        <p:grpSpPr>
+          <a:xfrm>
+            <a:off x="-8630" y="9294"/>
+            <a:ext cx="12199938" cy="186903"/>
+            <a:chOff x="-8630" y="9294"/>
+            <a:chExt cx="12199938" cy="186903"/>
+          </a:xfrm>
+        </p:grpSpPr>
+        <p:pic>
+          <p:nvPicPr>
+            <p:cNvPr id="20" name="Image 39">
+              <a:extLst>
+                <a:ext uri="{FF2B5EF4-FFF2-40B4-BE49-F238E27FC236}">
+                  <a16:creationId xmlns:a16="http://schemas.microsoft.com/office/drawing/2014/main" id="{458EBA9E-A986-86EC-59C2-57A3AB800D0D}"/>
+                </a:ext>
+              </a:extLst>
+            </p:cNvPr>
+            <p:cNvPicPr>
+              <a:picLocks noChangeAspect="1"/>
+            </p:cNvPicPr>
+            <p:nvPr/>
+          </p:nvPicPr>
+          <p:blipFill rotWithShape="1">
+            <a:blip r:embed="rId3" cstate="print">
+              <a:extLst>
+                <a:ext uri="{28A0092B-C50C-407E-A947-70E740481C1C}">
+                  <a14:useLocalDpi xmlns:a14="http://schemas.microsoft.com/office/drawing/2010/main" val="0"/>
+                </a:ext>
+              </a:extLst>
+            </a:blip>
+            <a:srcRect t="398"/>
+            <a:stretch/>
+          </p:blipFill>
+          <p:spPr bwMode="auto">
+            <a:xfrm rot="16200000" flipH="1">
+              <a:off x="3083618" y="-3082954"/>
+              <a:ext cx="184760" cy="6369256"/>
+            </a:xfrm>
+            <a:prstGeom prst="rect">
+              <a:avLst/>
+            </a:prstGeom>
+            <a:noFill/>
+            <a:ln>
+              <a:noFill/>
+            </a:ln>
+          </p:spPr>
+        </p:pic>
+        <p:pic>
+          <p:nvPicPr>
+            <p:cNvPr id="21" name="Image 39">
+              <a:extLst>
+                <a:ext uri="{FF2B5EF4-FFF2-40B4-BE49-F238E27FC236}">
+                  <a16:creationId xmlns:a16="http://schemas.microsoft.com/office/drawing/2014/main" id="{F7545980-CF10-E52F-BAFA-3FDA6FC8DE3C}"/>
+                </a:ext>
+              </a:extLst>
+            </p:cNvPr>
+            <p:cNvPicPr>
+              <a:picLocks noChangeAspect="1"/>
+            </p:cNvPicPr>
+            <p:nvPr/>
+          </p:nvPicPr>
+          <p:blipFill rotWithShape="1">
+            <a:blip r:embed="rId3" cstate="print">
+              <a:extLst>
+                <a:ext uri="{28A0092B-C50C-407E-A947-70E740481C1C}">
+                  <a14:useLocalDpi xmlns:a14="http://schemas.microsoft.com/office/drawing/2010/main" val="0"/>
+                </a:ext>
+              </a:extLst>
+            </a:blip>
+            <a:srcRect t="398"/>
+            <a:stretch/>
+          </p:blipFill>
+          <p:spPr bwMode="auto">
+            <a:xfrm rot="16200000" flipH="1">
+              <a:off x="8914300" y="-3080811"/>
+              <a:ext cx="184760" cy="6369256"/>
+            </a:xfrm>
+            <a:prstGeom prst="rect">
+              <a:avLst/>
+            </a:prstGeom>
+            <a:noFill/>
+            <a:ln>
+              <a:noFill/>
+            </a:ln>
+          </p:spPr>
+        </p:pic>
+      </p:grpSp>
     </p:spTree>
   </p:cSld>
   <p:clrMapOvr>
@@ -5505,6 +5703,105 @@
           </a:p>
         </p:txBody>
       </p:sp>
+      <p:grpSp>
+        <p:nvGrpSpPr>
+          <p:cNvPr id="35" name="Group 34">
+            <a:extLst>
+              <a:ext uri="{FF2B5EF4-FFF2-40B4-BE49-F238E27FC236}">
+                <a16:creationId xmlns:a16="http://schemas.microsoft.com/office/drawing/2014/main" id="{465F06CA-A168-62B4-F51F-A77892DC4FCF}"/>
+              </a:ext>
+            </a:extLst>
+          </p:cNvPr>
+          <p:cNvGrpSpPr/>
+          <p:nvPr/>
+        </p:nvGrpSpPr>
+        <p:grpSpPr>
+          <a:xfrm>
+            <a:off x="-8630" y="9294"/>
+            <a:ext cx="12199938" cy="186903"/>
+            <a:chOff x="-8630" y="9294"/>
+            <a:chExt cx="12199938" cy="186903"/>
+          </a:xfrm>
+        </p:grpSpPr>
+        <p:pic>
+          <p:nvPicPr>
+            <p:cNvPr id="36" name="Image 39">
+              <a:extLst>
+                <a:ext uri="{FF2B5EF4-FFF2-40B4-BE49-F238E27FC236}">
+                  <a16:creationId xmlns:a16="http://schemas.microsoft.com/office/drawing/2014/main" id="{00018096-F1C4-5B9B-5873-87C1E3B7B792}"/>
+                </a:ext>
+              </a:extLst>
+            </p:cNvPr>
+            <p:cNvPicPr>
+              <a:picLocks noChangeAspect="1"/>
+            </p:cNvPicPr>
+            <p:nvPr/>
+          </p:nvPicPr>
+          <p:blipFill rotWithShape="1">
+            <a:blip r:embed="rId3" cstate="print">
+              <a:extLst>
+                <a:ext uri="{28A0092B-C50C-407E-A947-70E740481C1C}">
+                  <a14:useLocalDpi xmlns:a14="http://schemas.microsoft.com/office/drawing/2010/main" val="0"/>
+                </a:ext>
+              </a:extLst>
+            </a:blip>
+            <a:srcRect t="398"/>
+            <a:stretch/>
+          </p:blipFill>
+          <p:spPr bwMode="auto">
+            <a:xfrm rot="16200000" flipH="1">
+              <a:off x="3083618" y="-3082954"/>
+              <a:ext cx="184760" cy="6369256"/>
+            </a:xfrm>
+            <a:prstGeom prst="rect">
+              <a:avLst/>
+            </a:prstGeom>
+            <a:noFill/>
+            <a:ln>
+              <a:noFill/>
+            </a:ln>
+          </p:spPr>
+        </p:pic>
+        <p:pic>
+          <p:nvPicPr>
+            <p:cNvPr id="37" name="Image 39">
+              <a:extLst>
+                <a:ext uri="{FF2B5EF4-FFF2-40B4-BE49-F238E27FC236}">
+                  <a16:creationId xmlns:a16="http://schemas.microsoft.com/office/drawing/2014/main" id="{BACC8CD2-3E8F-9476-60E0-823D8E3CBF83}"/>
+                </a:ext>
+              </a:extLst>
+            </p:cNvPr>
+            <p:cNvPicPr>
+              <a:picLocks noChangeAspect="1"/>
+            </p:cNvPicPr>
+            <p:nvPr/>
+          </p:nvPicPr>
+          <p:blipFill rotWithShape="1">
+            <a:blip r:embed="rId3" cstate="print">
+              <a:extLst>
+                <a:ext uri="{28A0092B-C50C-407E-A947-70E740481C1C}">
+                  <a14:useLocalDpi xmlns:a14="http://schemas.microsoft.com/office/drawing/2010/main" val="0"/>
+                </a:ext>
+              </a:extLst>
+            </a:blip>
+            <a:srcRect t="398"/>
+            <a:stretch/>
+          </p:blipFill>
+          <p:spPr bwMode="auto">
+            <a:xfrm rot="16200000" flipH="1">
+              <a:off x="8914300" y="-3080811"/>
+              <a:ext cx="184760" cy="6369256"/>
+            </a:xfrm>
+            <a:prstGeom prst="rect">
+              <a:avLst/>
+            </a:prstGeom>
+            <a:noFill/>
+            <a:ln>
+              <a:noFill/>
+            </a:ln>
+          </p:spPr>
+        </p:pic>
+      </p:grpSp>
     </p:spTree>
   </p:cSld>
   <p:clrMapOvr>
@@ -5924,6 +6221,105 @@
           </a:p>
         </p:txBody>
       </p:sp>
+      <p:grpSp>
+        <p:nvGrpSpPr>
+          <p:cNvPr id="13" name="Group 12">
+            <a:extLst>
+              <a:ext uri="{FF2B5EF4-FFF2-40B4-BE49-F238E27FC236}">
+                <a16:creationId xmlns:a16="http://schemas.microsoft.com/office/drawing/2014/main" id="{CAD08513-377E-EF62-2A09-419C1408F7F2}"/>
+              </a:ext>
+            </a:extLst>
+          </p:cNvPr>
+          <p:cNvGrpSpPr/>
+          <p:nvPr/>
+        </p:nvGrpSpPr>
+        <p:grpSpPr>
+          <a:xfrm>
+            <a:off x="-8630" y="9294"/>
+            <a:ext cx="12199938" cy="186903"/>
+            <a:chOff x="-8630" y="9294"/>
+            <a:chExt cx="12199938" cy="186903"/>
+          </a:xfrm>
+        </p:grpSpPr>
+        <p:pic>
+          <p:nvPicPr>
+            <p:cNvPr id="14" name="Image 39">
+              <a:extLst>
+                <a:ext uri="{FF2B5EF4-FFF2-40B4-BE49-F238E27FC236}">
+                  <a16:creationId xmlns:a16="http://schemas.microsoft.com/office/drawing/2014/main" id="{834EE51C-1D78-C58A-2FEA-9D0A994E1D5E}"/>
+                </a:ext>
+              </a:extLst>
+            </p:cNvPr>
+            <p:cNvPicPr>
+              <a:picLocks noChangeAspect="1"/>
+            </p:cNvPicPr>
+            <p:nvPr/>
+          </p:nvPicPr>
+          <p:blipFill rotWithShape="1">
+            <a:blip r:embed="rId3" cstate="print">
+              <a:extLst>
+                <a:ext uri="{28A0092B-C50C-407E-A947-70E740481C1C}">
+                  <a14:useLocalDpi xmlns:a14="http://schemas.microsoft.com/office/drawing/2010/main" val="0"/>
+                </a:ext>
+              </a:extLst>
+            </a:blip>
+            <a:srcRect t="398"/>
+            <a:stretch/>
+          </p:blipFill>
+          <p:spPr bwMode="auto">
+            <a:xfrm rot="16200000" flipH="1">
+              <a:off x="3083618" y="-3082954"/>
+              <a:ext cx="184760" cy="6369256"/>
+            </a:xfrm>
+            <a:prstGeom prst="rect">
+              <a:avLst/>
+            </a:prstGeom>
+            <a:noFill/>
+            <a:ln>
+              <a:noFill/>
+            </a:ln>
+          </p:spPr>
+        </p:pic>
+        <p:pic>
+          <p:nvPicPr>
+            <p:cNvPr id="15" name="Image 39">
+              <a:extLst>
+                <a:ext uri="{FF2B5EF4-FFF2-40B4-BE49-F238E27FC236}">
+                  <a16:creationId xmlns:a16="http://schemas.microsoft.com/office/drawing/2014/main" id="{93FCC32B-1E32-1C10-D229-42A128A6D98F}"/>
+                </a:ext>
+              </a:extLst>
+            </p:cNvPr>
+            <p:cNvPicPr>
+              <a:picLocks noChangeAspect="1"/>
+            </p:cNvPicPr>
+            <p:nvPr/>
+          </p:nvPicPr>
+          <p:blipFill rotWithShape="1">
+            <a:blip r:embed="rId3" cstate="print">
+              <a:extLst>
+                <a:ext uri="{28A0092B-C50C-407E-A947-70E740481C1C}">
+                  <a14:useLocalDpi xmlns:a14="http://schemas.microsoft.com/office/drawing/2010/main" val="0"/>
+                </a:ext>
+              </a:extLst>
+            </a:blip>
+            <a:srcRect t="398"/>
+            <a:stretch/>
+          </p:blipFill>
+          <p:spPr bwMode="auto">
+            <a:xfrm rot="16200000" flipH="1">
+              <a:off x="8914300" y="-3080811"/>
+              <a:ext cx="184760" cy="6369256"/>
+            </a:xfrm>
+            <a:prstGeom prst="rect">
+              <a:avLst/>
+            </a:prstGeom>
+            <a:noFill/>
+            <a:ln>
+              <a:noFill/>
+            </a:ln>
+          </p:spPr>
+        </p:pic>
+      </p:grpSp>
     </p:spTree>
   </p:cSld>
   <p:clrMapOvr>
@@ -7888,84 +8284,105 @@
           </a:p>
         </p:txBody>
       </p:sp>
-      <p:pic>
-        <p:nvPicPr>
-          <p:cNvPr id="61" name="Image 39">
+      <p:grpSp>
+        <p:nvGrpSpPr>
+          <p:cNvPr id="63" name="Group 62">
             <a:extLst>
               <a:ext uri="{FF2B5EF4-FFF2-40B4-BE49-F238E27FC236}">
-                <a16:creationId xmlns:a16="http://schemas.microsoft.com/office/drawing/2014/main" id="{53DE72C1-4DD3-8699-7351-780D07812EAB}"/>
+                <a16:creationId xmlns:a16="http://schemas.microsoft.com/office/drawing/2014/main" id="{6B80B650-3FCB-CAE3-A2FE-8BB11EB02734}"/>
               </a:ext>
             </a:extLst>
           </p:cNvPr>
-          <p:cNvPicPr>
-            <a:picLocks noChangeAspect="1"/>
-          </p:cNvPicPr>
-          <p:nvPr/>
-        </p:nvPicPr>
-        <p:blipFill rotWithShape="1">
-          <a:blip r:embed="rId3" cstate="print">
-            <a:extLst>
-              <a:ext uri="{28A0092B-C50C-407E-A947-70E740481C1C}">
-                <a14:useLocalDpi xmlns:a14="http://schemas.microsoft.com/office/drawing/2010/main" val="0"/>
-              </a:ext>
-            </a:extLst>
-          </a:blip>
-          <a:srcRect t="398"/>
-          <a:stretch/>
-        </p:blipFill>
-        <p:spPr bwMode="auto">
-          <a:xfrm rot="16200000" flipH="1">
-            <a:off x="3083618" y="-3082954"/>
-            <a:ext cx="184760" cy="6369256"/>
-          </a:xfrm>
-          <a:prstGeom prst="rect">
-            <a:avLst/>
-          </a:prstGeom>
-          <a:noFill/>
-          <a:ln>
+          <p:cNvGrpSpPr/>
+          <p:nvPr/>
+        </p:nvGrpSpPr>
+        <p:grpSpPr>
+          <a:xfrm>
+            <a:off x="-8630" y="9294"/>
+            <a:ext cx="12199938" cy="186903"/>
+            <a:chOff x="-8630" y="9294"/>
+            <a:chExt cx="12199938" cy="186903"/>
+          </a:xfrm>
+        </p:grpSpPr>
+        <p:pic>
+          <p:nvPicPr>
+            <p:cNvPr id="61" name="Image 39">
+              <a:extLst>
+                <a:ext uri="{FF2B5EF4-FFF2-40B4-BE49-F238E27FC236}">
+                  <a16:creationId xmlns:a16="http://schemas.microsoft.com/office/drawing/2014/main" id="{53DE72C1-4DD3-8699-7351-780D07812EAB}"/>
+                </a:ext>
+              </a:extLst>
+            </p:cNvPr>
+            <p:cNvPicPr>
+              <a:picLocks noChangeAspect="1"/>
+            </p:cNvPicPr>
+            <p:nvPr/>
+          </p:nvPicPr>
+          <p:blipFill rotWithShape="1">
+            <a:blip r:embed="rId3" cstate="print">
+              <a:extLst>
+                <a:ext uri="{28A0092B-C50C-407E-A947-70E740481C1C}">
+                  <a14:useLocalDpi xmlns:a14="http://schemas.microsoft.com/office/drawing/2010/main" val="0"/>
+                </a:ext>
+              </a:extLst>
+            </a:blip>
+            <a:srcRect t="398"/>
+            <a:stretch/>
+          </p:blipFill>
+          <p:spPr bwMode="auto">
+            <a:xfrm rot="16200000" flipH="1">
+              <a:off x="3083618" y="-3082954"/>
+              <a:ext cx="184760" cy="6369256"/>
+            </a:xfrm>
+            <a:prstGeom prst="rect">
+              <a:avLst/>
+            </a:prstGeom>
             <a:noFill/>
-          </a:ln>
-        </p:spPr>
-      </p:pic>
-      <p:pic>
-        <p:nvPicPr>
-          <p:cNvPr id="62" name="Image 39">
-            <a:extLst>
-              <a:ext uri="{FF2B5EF4-FFF2-40B4-BE49-F238E27FC236}">
-                <a16:creationId xmlns:a16="http://schemas.microsoft.com/office/drawing/2014/main" id="{142A31A2-416C-E1B6-66C1-4CA95737D32F}"/>
-              </a:ext>
-            </a:extLst>
-          </p:cNvPr>
-          <p:cNvPicPr>
-            <a:picLocks noChangeAspect="1"/>
-          </p:cNvPicPr>
-          <p:nvPr/>
-        </p:nvPicPr>
-        <p:blipFill rotWithShape="1">
-          <a:blip r:embed="rId3" cstate="print">
-            <a:extLst>
-              <a:ext uri="{28A0092B-C50C-407E-A947-70E740481C1C}">
-                <a14:useLocalDpi xmlns:a14="http://schemas.microsoft.com/office/drawing/2010/main" val="0"/>
-              </a:ext>
-            </a:extLst>
-          </a:blip>
-          <a:srcRect t="398"/>
-          <a:stretch/>
-        </p:blipFill>
-        <p:spPr bwMode="auto">
-          <a:xfrm rot="16200000" flipH="1">
-            <a:off x="8914300" y="-3080811"/>
-            <a:ext cx="184760" cy="6369256"/>
-          </a:xfrm>
-          <a:prstGeom prst="rect">
-            <a:avLst/>
-          </a:prstGeom>
-          <a:noFill/>
-          <a:ln>
+            <a:ln>
+              <a:noFill/>
+            </a:ln>
+          </p:spPr>
+        </p:pic>
+        <p:pic>
+          <p:nvPicPr>
+            <p:cNvPr id="62" name="Image 39">
+              <a:extLst>
+                <a:ext uri="{FF2B5EF4-FFF2-40B4-BE49-F238E27FC236}">
+                  <a16:creationId xmlns:a16="http://schemas.microsoft.com/office/drawing/2014/main" id="{142A31A2-416C-E1B6-66C1-4CA95737D32F}"/>
+                </a:ext>
+              </a:extLst>
+            </p:cNvPr>
+            <p:cNvPicPr>
+              <a:picLocks noChangeAspect="1"/>
+            </p:cNvPicPr>
+            <p:nvPr/>
+          </p:nvPicPr>
+          <p:blipFill rotWithShape="1">
+            <a:blip r:embed="rId3" cstate="print">
+              <a:extLst>
+                <a:ext uri="{28A0092B-C50C-407E-A947-70E740481C1C}">
+                  <a14:useLocalDpi xmlns:a14="http://schemas.microsoft.com/office/drawing/2010/main" val="0"/>
+                </a:ext>
+              </a:extLst>
+            </a:blip>
+            <a:srcRect t="398"/>
+            <a:stretch/>
+          </p:blipFill>
+          <p:spPr bwMode="auto">
+            <a:xfrm rot="16200000" flipH="1">
+              <a:off x="8914300" y="-3080811"/>
+              <a:ext cx="184760" cy="6369256"/>
+            </a:xfrm>
+            <a:prstGeom prst="rect">
+              <a:avLst/>
+            </a:prstGeom>
             <a:noFill/>
-          </a:ln>
-        </p:spPr>
-      </p:pic>
+            <a:ln>
+              <a:noFill/>
+            </a:ln>
+          </p:spPr>
+        </p:pic>
+      </p:grpSp>
     </p:spTree>
   </p:cSld>
   <p:clrMapOvr>
@@ -8920,6 +9337,105 @@
           </a:p>
         </p:txBody>
       </p:sp>
+      <p:grpSp>
+        <p:nvGrpSpPr>
+          <p:cNvPr id="30" name="Group 29">
+            <a:extLst>
+              <a:ext uri="{FF2B5EF4-FFF2-40B4-BE49-F238E27FC236}">
+                <a16:creationId xmlns:a16="http://schemas.microsoft.com/office/drawing/2014/main" id="{EF29607D-D23C-9E58-B116-CC566D814F1D}"/>
+              </a:ext>
+            </a:extLst>
+          </p:cNvPr>
+          <p:cNvGrpSpPr/>
+          <p:nvPr/>
+        </p:nvGrpSpPr>
+        <p:grpSpPr>
+          <a:xfrm>
+            <a:off x="-8630" y="9294"/>
+            <a:ext cx="12199938" cy="186903"/>
+            <a:chOff x="-8630" y="9294"/>
+            <a:chExt cx="12199938" cy="186903"/>
+          </a:xfrm>
+        </p:grpSpPr>
+        <p:pic>
+          <p:nvPicPr>
+            <p:cNvPr id="31" name="Image 39">
+              <a:extLst>
+                <a:ext uri="{FF2B5EF4-FFF2-40B4-BE49-F238E27FC236}">
+                  <a16:creationId xmlns:a16="http://schemas.microsoft.com/office/drawing/2014/main" id="{F389E4C0-F11A-CCFE-63F1-38B5DC17F6EA}"/>
+                </a:ext>
+              </a:extLst>
+            </p:cNvPr>
+            <p:cNvPicPr>
+              <a:picLocks noChangeAspect="1"/>
+            </p:cNvPicPr>
+            <p:nvPr/>
+          </p:nvPicPr>
+          <p:blipFill rotWithShape="1">
+            <a:blip r:embed="rId3" cstate="print">
+              <a:extLst>
+                <a:ext uri="{28A0092B-C50C-407E-A947-70E740481C1C}">
+                  <a14:useLocalDpi xmlns:a14="http://schemas.microsoft.com/office/drawing/2010/main" val="0"/>
+                </a:ext>
+              </a:extLst>
+            </a:blip>
+            <a:srcRect t="398"/>
+            <a:stretch/>
+          </p:blipFill>
+          <p:spPr bwMode="auto">
+            <a:xfrm rot="16200000" flipH="1">
+              <a:off x="3083618" y="-3082954"/>
+              <a:ext cx="184760" cy="6369256"/>
+            </a:xfrm>
+            <a:prstGeom prst="rect">
+              <a:avLst/>
+            </a:prstGeom>
+            <a:noFill/>
+            <a:ln>
+              <a:noFill/>
+            </a:ln>
+          </p:spPr>
+        </p:pic>
+        <p:pic>
+          <p:nvPicPr>
+            <p:cNvPr id="32" name="Image 39">
+              <a:extLst>
+                <a:ext uri="{FF2B5EF4-FFF2-40B4-BE49-F238E27FC236}">
+                  <a16:creationId xmlns:a16="http://schemas.microsoft.com/office/drawing/2014/main" id="{5DCA518A-CF80-26C0-FC3F-C0AF9B863C34}"/>
+                </a:ext>
+              </a:extLst>
+            </p:cNvPr>
+            <p:cNvPicPr>
+              <a:picLocks noChangeAspect="1"/>
+            </p:cNvPicPr>
+            <p:nvPr/>
+          </p:nvPicPr>
+          <p:blipFill rotWithShape="1">
+            <a:blip r:embed="rId3" cstate="print">
+              <a:extLst>
+                <a:ext uri="{28A0092B-C50C-407E-A947-70E740481C1C}">
+                  <a14:useLocalDpi xmlns:a14="http://schemas.microsoft.com/office/drawing/2010/main" val="0"/>
+                </a:ext>
+              </a:extLst>
+            </a:blip>
+            <a:srcRect t="398"/>
+            <a:stretch/>
+          </p:blipFill>
+          <p:spPr bwMode="auto">
+            <a:xfrm rot="16200000" flipH="1">
+              <a:off x="8914300" y="-3080811"/>
+              <a:ext cx="184760" cy="6369256"/>
+            </a:xfrm>
+            <a:prstGeom prst="rect">
+              <a:avLst/>
+            </a:prstGeom>
+            <a:noFill/>
+            <a:ln>
+              <a:noFill/>
+            </a:ln>
+          </p:spPr>
+        </p:pic>
+      </p:grpSp>
     </p:spTree>
   </p:cSld>
   <p:clrMapOvr>
@@ -10032,6 +10548,105 @@
           </a:p>
         </p:txBody>
       </p:sp>
+      <p:grpSp>
+        <p:nvGrpSpPr>
+          <p:cNvPr id="33" name="Group 32">
+            <a:extLst>
+              <a:ext uri="{FF2B5EF4-FFF2-40B4-BE49-F238E27FC236}">
+                <a16:creationId xmlns:a16="http://schemas.microsoft.com/office/drawing/2014/main" id="{A5511C2B-3AA4-B2AE-C93E-F8A3BC5EF910}"/>
+              </a:ext>
+            </a:extLst>
+          </p:cNvPr>
+          <p:cNvGrpSpPr/>
+          <p:nvPr/>
+        </p:nvGrpSpPr>
+        <p:grpSpPr>
+          <a:xfrm>
+            <a:off x="-8630" y="9294"/>
+            <a:ext cx="12199938" cy="186903"/>
+            <a:chOff x="-8630" y="9294"/>
+            <a:chExt cx="12199938" cy="186903"/>
+          </a:xfrm>
+        </p:grpSpPr>
+        <p:pic>
+          <p:nvPicPr>
+            <p:cNvPr id="34" name="Image 39">
+              <a:extLst>
+                <a:ext uri="{FF2B5EF4-FFF2-40B4-BE49-F238E27FC236}">
+                  <a16:creationId xmlns:a16="http://schemas.microsoft.com/office/drawing/2014/main" id="{CFC352C3-794A-1E5A-D96F-78C1CF285DA9}"/>
+                </a:ext>
+              </a:extLst>
+            </p:cNvPr>
+            <p:cNvPicPr>
+              <a:picLocks noChangeAspect="1"/>
+            </p:cNvPicPr>
+            <p:nvPr/>
+          </p:nvPicPr>
+          <p:blipFill rotWithShape="1">
+            <a:blip r:embed="rId3" cstate="print">
+              <a:extLst>
+                <a:ext uri="{28A0092B-C50C-407E-A947-70E740481C1C}">
+                  <a14:useLocalDpi xmlns:a14="http://schemas.microsoft.com/office/drawing/2010/main" val="0"/>
+                </a:ext>
+              </a:extLst>
+            </a:blip>
+            <a:srcRect t="398"/>
+            <a:stretch/>
+          </p:blipFill>
+          <p:spPr bwMode="auto">
+            <a:xfrm rot="16200000" flipH="1">
+              <a:off x="3083618" y="-3082954"/>
+              <a:ext cx="184760" cy="6369256"/>
+            </a:xfrm>
+            <a:prstGeom prst="rect">
+              <a:avLst/>
+            </a:prstGeom>
+            <a:noFill/>
+            <a:ln>
+              <a:noFill/>
+            </a:ln>
+          </p:spPr>
+        </p:pic>
+        <p:pic>
+          <p:nvPicPr>
+            <p:cNvPr id="35" name="Image 39">
+              <a:extLst>
+                <a:ext uri="{FF2B5EF4-FFF2-40B4-BE49-F238E27FC236}">
+                  <a16:creationId xmlns:a16="http://schemas.microsoft.com/office/drawing/2014/main" id="{D6994452-DC6A-2D20-536E-6B0CB1C6330D}"/>
+                </a:ext>
+              </a:extLst>
+            </p:cNvPr>
+            <p:cNvPicPr>
+              <a:picLocks noChangeAspect="1"/>
+            </p:cNvPicPr>
+            <p:nvPr/>
+          </p:nvPicPr>
+          <p:blipFill rotWithShape="1">
+            <a:blip r:embed="rId3" cstate="print">
+              <a:extLst>
+                <a:ext uri="{28A0092B-C50C-407E-A947-70E740481C1C}">
+                  <a14:useLocalDpi xmlns:a14="http://schemas.microsoft.com/office/drawing/2010/main" val="0"/>
+                </a:ext>
+              </a:extLst>
+            </a:blip>
+            <a:srcRect t="398"/>
+            <a:stretch/>
+          </p:blipFill>
+          <p:spPr bwMode="auto">
+            <a:xfrm rot="16200000" flipH="1">
+              <a:off x="8914300" y="-3080811"/>
+              <a:ext cx="184760" cy="6369256"/>
+            </a:xfrm>
+            <a:prstGeom prst="rect">
+              <a:avLst/>
+            </a:prstGeom>
+            <a:noFill/>
+            <a:ln>
+              <a:noFill/>
+            </a:ln>
+          </p:spPr>
+        </p:pic>
+      </p:grpSp>
     </p:spTree>
   </p:cSld>
   <p:clrMapOvr>
@@ -11082,6 +11697,105 @@
           </a:p>
         </p:txBody>
       </p:sp>
+      <p:grpSp>
+        <p:nvGrpSpPr>
+          <p:cNvPr id="34" name="Group 33">
+            <a:extLst>
+              <a:ext uri="{FF2B5EF4-FFF2-40B4-BE49-F238E27FC236}">
+                <a16:creationId xmlns:a16="http://schemas.microsoft.com/office/drawing/2014/main" id="{66B4DB73-2BCA-F09A-9A60-1B8247B71350}"/>
+              </a:ext>
+            </a:extLst>
+          </p:cNvPr>
+          <p:cNvGrpSpPr/>
+          <p:nvPr/>
+        </p:nvGrpSpPr>
+        <p:grpSpPr>
+          <a:xfrm>
+            <a:off x="-8630" y="9294"/>
+            <a:ext cx="12199938" cy="186903"/>
+            <a:chOff x="-8630" y="9294"/>
+            <a:chExt cx="12199938" cy="186903"/>
+          </a:xfrm>
+        </p:grpSpPr>
+        <p:pic>
+          <p:nvPicPr>
+            <p:cNvPr id="35" name="Image 39">
+              <a:extLst>
+                <a:ext uri="{FF2B5EF4-FFF2-40B4-BE49-F238E27FC236}">
+                  <a16:creationId xmlns:a16="http://schemas.microsoft.com/office/drawing/2014/main" id="{11CA6A51-41EB-A5DF-C0F4-4B08D1AAB80E}"/>
+                </a:ext>
+              </a:extLst>
+            </p:cNvPr>
+            <p:cNvPicPr>
+              <a:picLocks noChangeAspect="1"/>
+            </p:cNvPicPr>
+            <p:nvPr/>
+          </p:nvPicPr>
+          <p:blipFill rotWithShape="1">
+            <a:blip r:embed="rId3" cstate="print">
+              <a:extLst>
+                <a:ext uri="{28A0092B-C50C-407E-A947-70E740481C1C}">
+                  <a14:useLocalDpi xmlns:a14="http://schemas.microsoft.com/office/drawing/2010/main" val="0"/>
+                </a:ext>
+              </a:extLst>
+            </a:blip>
+            <a:srcRect t="398"/>
+            <a:stretch/>
+          </p:blipFill>
+          <p:spPr bwMode="auto">
+            <a:xfrm rot="16200000" flipH="1">
+              <a:off x="3083618" y="-3082954"/>
+              <a:ext cx="184760" cy="6369256"/>
+            </a:xfrm>
+            <a:prstGeom prst="rect">
+              <a:avLst/>
+            </a:prstGeom>
+            <a:noFill/>
+            <a:ln>
+              <a:noFill/>
+            </a:ln>
+          </p:spPr>
+        </p:pic>
+        <p:pic>
+          <p:nvPicPr>
+            <p:cNvPr id="36" name="Image 39">
+              <a:extLst>
+                <a:ext uri="{FF2B5EF4-FFF2-40B4-BE49-F238E27FC236}">
+                  <a16:creationId xmlns:a16="http://schemas.microsoft.com/office/drawing/2014/main" id="{549A14A2-157B-0FE5-C385-1C64AC58D800}"/>
+                </a:ext>
+              </a:extLst>
+            </p:cNvPr>
+            <p:cNvPicPr>
+              <a:picLocks noChangeAspect="1"/>
+            </p:cNvPicPr>
+            <p:nvPr/>
+          </p:nvPicPr>
+          <p:blipFill rotWithShape="1">
+            <a:blip r:embed="rId3" cstate="print">
+              <a:extLst>
+                <a:ext uri="{28A0092B-C50C-407E-A947-70E740481C1C}">
+                  <a14:useLocalDpi xmlns:a14="http://schemas.microsoft.com/office/drawing/2010/main" val="0"/>
+                </a:ext>
+              </a:extLst>
+            </a:blip>
+            <a:srcRect t="398"/>
+            <a:stretch/>
+          </p:blipFill>
+          <p:spPr bwMode="auto">
+            <a:xfrm rot="16200000" flipH="1">
+              <a:off x="8914300" y="-3080811"/>
+              <a:ext cx="184760" cy="6369256"/>
+            </a:xfrm>
+            <a:prstGeom prst="rect">
+              <a:avLst/>
+            </a:prstGeom>
+            <a:noFill/>
+            <a:ln>
+              <a:noFill/>
+            </a:ln>
+          </p:spPr>
+        </p:pic>
+      </p:grpSp>
     </p:spTree>
   </p:cSld>
   <p:clrMapOvr>
@@ -12483,6 +13197,105 @@
           </a:p>
         </p:txBody>
       </p:sp>
+      <p:grpSp>
+        <p:nvGrpSpPr>
+          <p:cNvPr id="44" name="Group 43">
+            <a:extLst>
+              <a:ext uri="{FF2B5EF4-FFF2-40B4-BE49-F238E27FC236}">
+                <a16:creationId xmlns:a16="http://schemas.microsoft.com/office/drawing/2014/main" id="{955FFF17-5ED6-EBFA-6DB7-E15A65EB2214}"/>
+              </a:ext>
+            </a:extLst>
+          </p:cNvPr>
+          <p:cNvGrpSpPr/>
+          <p:nvPr/>
+        </p:nvGrpSpPr>
+        <p:grpSpPr>
+          <a:xfrm>
+            <a:off x="-8630" y="9294"/>
+            <a:ext cx="12199938" cy="186903"/>
+            <a:chOff x="-8630" y="9294"/>
+            <a:chExt cx="12199938" cy="186903"/>
+          </a:xfrm>
+        </p:grpSpPr>
+        <p:pic>
+          <p:nvPicPr>
+            <p:cNvPr id="45" name="Image 39">
+              <a:extLst>
+                <a:ext uri="{FF2B5EF4-FFF2-40B4-BE49-F238E27FC236}">
+                  <a16:creationId xmlns:a16="http://schemas.microsoft.com/office/drawing/2014/main" id="{35E0762F-517A-1B1A-271D-1BA1C7A35275}"/>
+                </a:ext>
+              </a:extLst>
+            </p:cNvPr>
+            <p:cNvPicPr>
+              <a:picLocks noChangeAspect="1"/>
+            </p:cNvPicPr>
+            <p:nvPr/>
+          </p:nvPicPr>
+          <p:blipFill rotWithShape="1">
+            <a:blip r:embed="rId3" cstate="print">
+              <a:extLst>
+                <a:ext uri="{28A0092B-C50C-407E-A947-70E740481C1C}">
+                  <a14:useLocalDpi xmlns:a14="http://schemas.microsoft.com/office/drawing/2010/main" val="0"/>
+                </a:ext>
+              </a:extLst>
+            </a:blip>
+            <a:srcRect t="398"/>
+            <a:stretch/>
+          </p:blipFill>
+          <p:spPr bwMode="auto">
+            <a:xfrm rot="16200000" flipH="1">
+              <a:off x="3083618" y="-3082954"/>
+              <a:ext cx="184760" cy="6369256"/>
+            </a:xfrm>
+            <a:prstGeom prst="rect">
+              <a:avLst/>
+            </a:prstGeom>
+            <a:noFill/>
+            <a:ln>
+              <a:noFill/>
+            </a:ln>
+          </p:spPr>
+        </p:pic>
+        <p:pic>
+          <p:nvPicPr>
+            <p:cNvPr id="46" name="Image 39">
+              <a:extLst>
+                <a:ext uri="{FF2B5EF4-FFF2-40B4-BE49-F238E27FC236}">
+                  <a16:creationId xmlns:a16="http://schemas.microsoft.com/office/drawing/2014/main" id="{4ACAEB00-CC5E-274C-3ADC-B62AEC1CB418}"/>
+                </a:ext>
+              </a:extLst>
+            </p:cNvPr>
+            <p:cNvPicPr>
+              <a:picLocks noChangeAspect="1"/>
+            </p:cNvPicPr>
+            <p:nvPr/>
+          </p:nvPicPr>
+          <p:blipFill rotWithShape="1">
+            <a:blip r:embed="rId3" cstate="print">
+              <a:extLst>
+                <a:ext uri="{28A0092B-C50C-407E-A947-70E740481C1C}">
+                  <a14:useLocalDpi xmlns:a14="http://schemas.microsoft.com/office/drawing/2010/main" val="0"/>
+                </a:ext>
+              </a:extLst>
+            </a:blip>
+            <a:srcRect t="398"/>
+            <a:stretch/>
+          </p:blipFill>
+          <p:spPr bwMode="auto">
+            <a:xfrm rot="16200000" flipH="1">
+              <a:off x="8914300" y="-3080811"/>
+              <a:ext cx="184760" cy="6369256"/>
+            </a:xfrm>
+            <a:prstGeom prst="rect">
+              <a:avLst/>
+            </a:prstGeom>
+            <a:noFill/>
+            <a:ln>
+              <a:noFill/>
+            </a:ln>
+          </p:spPr>
+        </p:pic>
+      </p:grpSp>
     </p:spTree>
   </p:cSld>
   <p:clrMapOvr>
@@ -13363,6 +14176,105 @@
           </a:p>
         </p:txBody>
       </p:sp>
+      <p:grpSp>
+        <p:nvGrpSpPr>
+          <p:cNvPr id="21" name="Group 20">
+            <a:extLst>
+              <a:ext uri="{FF2B5EF4-FFF2-40B4-BE49-F238E27FC236}">
+                <a16:creationId xmlns:a16="http://schemas.microsoft.com/office/drawing/2014/main" id="{F340352C-427A-414B-67E3-1B7B98E16D5B}"/>
+              </a:ext>
+            </a:extLst>
+          </p:cNvPr>
+          <p:cNvGrpSpPr/>
+          <p:nvPr/>
+        </p:nvGrpSpPr>
+        <p:grpSpPr>
+          <a:xfrm>
+            <a:off x="-8630" y="9294"/>
+            <a:ext cx="12199938" cy="186903"/>
+            <a:chOff x="-8630" y="9294"/>
+            <a:chExt cx="12199938" cy="186903"/>
+          </a:xfrm>
+        </p:grpSpPr>
+        <p:pic>
+          <p:nvPicPr>
+            <p:cNvPr id="22" name="Image 39">
+              <a:extLst>
+                <a:ext uri="{FF2B5EF4-FFF2-40B4-BE49-F238E27FC236}">
+                  <a16:creationId xmlns:a16="http://schemas.microsoft.com/office/drawing/2014/main" id="{3F13A704-0773-07D1-3812-7F643B6EC2D4}"/>
+                </a:ext>
+              </a:extLst>
+            </p:cNvPr>
+            <p:cNvPicPr>
+              <a:picLocks noChangeAspect="1"/>
+            </p:cNvPicPr>
+            <p:nvPr/>
+          </p:nvPicPr>
+          <p:blipFill rotWithShape="1">
+            <a:blip r:embed="rId3" cstate="print">
+              <a:extLst>
+                <a:ext uri="{28A0092B-C50C-407E-A947-70E740481C1C}">
+                  <a14:useLocalDpi xmlns:a14="http://schemas.microsoft.com/office/drawing/2010/main" val="0"/>
+                </a:ext>
+              </a:extLst>
+            </a:blip>
+            <a:srcRect t="398"/>
+            <a:stretch/>
+          </p:blipFill>
+          <p:spPr bwMode="auto">
+            <a:xfrm rot="16200000" flipH="1">
+              <a:off x="3083618" y="-3082954"/>
+              <a:ext cx="184760" cy="6369256"/>
+            </a:xfrm>
+            <a:prstGeom prst="rect">
+              <a:avLst/>
+            </a:prstGeom>
+            <a:noFill/>
+            <a:ln>
+              <a:noFill/>
+            </a:ln>
+          </p:spPr>
+        </p:pic>
+        <p:pic>
+          <p:nvPicPr>
+            <p:cNvPr id="23" name="Image 39">
+              <a:extLst>
+                <a:ext uri="{FF2B5EF4-FFF2-40B4-BE49-F238E27FC236}">
+                  <a16:creationId xmlns:a16="http://schemas.microsoft.com/office/drawing/2014/main" id="{0E03677C-2173-151D-CC40-36DBD0C6C07E}"/>
+                </a:ext>
+              </a:extLst>
+            </p:cNvPr>
+            <p:cNvPicPr>
+              <a:picLocks noChangeAspect="1"/>
+            </p:cNvPicPr>
+            <p:nvPr/>
+          </p:nvPicPr>
+          <p:blipFill rotWithShape="1">
+            <a:blip r:embed="rId3" cstate="print">
+              <a:extLst>
+                <a:ext uri="{28A0092B-C50C-407E-A947-70E740481C1C}">
+                  <a14:useLocalDpi xmlns:a14="http://schemas.microsoft.com/office/drawing/2010/main" val="0"/>
+                </a:ext>
+              </a:extLst>
+            </a:blip>
+            <a:srcRect t="398"/>
+            <a:stretch/>
+          </p:blipFill>
+          <p:spPr bwMode="auto">
+            <a:xfrm rot="16200000" flipH="1">
+              <a:off x="8914300" y="-3080811"/>
+              <a:ext cx="184760" cy="6369256"/>
+            </a:xfrm>
+            <a:prstGeom prst="rect">
+              <a:avLst/>
+            </a:prstGeom>
+            <a:noFill/>
+            <a:ln>
+              <a:noFill/>
+            </a:ln>
+          </p:spPr>
+        </p:pic>
+      </p:grpSp>
     </p:spTree>
   </p:cSld>
   <p:clrMapOvr>
@@ -14159,6 +15071,105 @@
           </a:p>
         </p:txBody>
       </p:sp>
+      <p:grpSp>
+        <p:nvGrpSpPr>
+          <p:cNvPr id="20" name="Group 19">
+            <a:extLst>
+              <a:ext uri="{FF2B5EF4-FFF2-40B4-BE49-F238E27FC236}">
+                <a16:creationId xmlns:a16="http://schemas.microsoft.com/office/drawing/2014/main" id="{DA080ACE-131D-FD97-28CE-35C9B29F7C5E}"/>
+              </a:ext>
+            </a:extLst>
+          </p:cNvPr>
+          <p:cNvGrpSpPr/>
+          <p:nvPr/>
+        </p:nvGrpSpPr>
+        <p:grpSpPr>
+          <a:xfrm>
+            <a:off x="-8630" y="9294"/>
+            <a:ext cx="12199938" cy="186903"/>
+            <a:chOff x="-8630" y="9294"/>
+            <a:chExt cx="12199938" cy="186903"/>
+          </a:xfrm>
+        </p:grpSpPr>
+        <p:pic>
+          <p:nvPicPr>
+            <p:cNvPr id="21" name="Image 39">
+              <a:extLst>
+                <a:ext uri="{FF2B5EF4-FFF2-40B4-BE49-F238E27FC236}">
+                  <a16:creationId xmlns:a16="http://schemas.microsoft.com/office/drawing/2014/main" id="{9E0201BD-DC4F-494C-48F3-7BF747082A17}"/>
+                </a:ext>
+              </a:extLst>
+            </p:cNvPr>
+            <p:cNvPicPr>
+              <a:picLocks noChangeAspect="1"/>
+            </p:cNvPicPr>
+            <p:nvPr/>
+          </p:nvPicPr>
+          <p:blipFill rotWithShape="1">
+            <a:blip r:embed="rId3" cstate="print">
+              <a:extLst>
+                <a:ext uri="{28A0092B-C50C-407E-A947-70E740481C1C}">
+                  <a14:useLocalDpi xmlns:a14="http://schemas.microsoft.com/office/drawing/2010/main" val="0"/>
+                </a:ext>
+              </a:extLst>
+            </a:blip>
+            <a:srcRect t="398"/>
+            <a:stretch/>
+          </p:blipFill>
+          <p:spPr bwMode="auto">
+            <a:xfrm rot="16200000" flipH="1">
+              <a:off x="3083618" y="-3082954"/>
+              <a:ext cx="184760" cy="6369256"/>
+            </a:xfrm>
+            <a:prstGeom prst="rect">
+              <a:avLst/>
+            </a:prstGeom>
+            <a:noFill/>
+            <a:ln>
+              <a:noFill/>
+            </a:ln>
+          </p:spPr>
+        </p:pic>
+        <p:pic>
+          <p:nvPicPr>
+            <p:cNvPr id="22" name="Image 39">
+              <a:extLst>
+                <a:ext uri="{FF2B5EF4-FFF2-40B4-BE49-F238E27FC236}">
+                  <a16:creationId xmlns:a16="http://schemas.microsoft.com/office/drawing/2014/main" id="{58E509B7-2844-E8C4-05AF-B626EDD1234A}"/>
+                </a:ext>
+              </a:extLst>
+            </p:cNvPr>
+            <p:cNvPicPr>
+              <a:picLocks noChangeAspect="1"/>
+            </p:cNvPicPr>
+            <p:nvPr/>
+          </p:nvPicPr>
+          <p:blipFill rotWithShape="1">
+            <a:blip r:embed="rId3" cstate="print">
+              <a:extLst>
+                <a:ext uri="{28A0092B-C50C-407E-A947-70E740481C1C}">
+                  <a14:useLocalDpi xmlns:a14="http://schemas.microsoft.com/office/drawing/2010/main" val="0"/>
+                </a:ext>
+              </a:extLst>
+            </a:blip>
+            <a:srcRect t="398"/>
+            <a:stretch/>
+          </p:blipFill>
+          <p:spPr bwMode="auto">
+            <a:xfrm rot="16200000" flipH="1">
+              <a:off x="8914300" y="-3080811"/>
+              <a:ext cx="184760" cy="6369256"/>
+            </a:xfrm>
+            <a:prstGeom prst="rect">
+              <a:avLst/>
+            </a:prstGeom>
+            <a:noFill/>
+            <a:ln>
+              <a:noFill/>
+            </a:ln>
+          </p:spPr>
+        </p:pic>
+      </p:grpSp>
     </p:spTree>
   </p:cSld>
   <p:clrMapOvr>
@@ -15106,6 +16117,105 @@
           </a:p>
         </p:txBody>
       </p:sp>
+      <p:grpSp>
+        <p:nvGrpSpPr>
+          <p:cNvPr id="26" name="Group 25">
+            <a:extLst>
+              <a:ext uri="{FF2B5EF4-FFF2-40B4-BE49-F238E27FC236}">
+                <a16:creationId xmlns:a16="http://schemas.microsoft.com/office/drawing/2014/main" id="{D6B5AB82-B702-F089-5A7A-5B867880978D}"/>
+              </a:ext>
+            </a:extLst>
+          </p:cNvPr>
+          <p:cNvGrpSpPr/>
+          <p:nvPr/>
+        </p:nvGrpSpPr>
+        <p:grpSpPr>
+          <a:xfrm>
+            <a:off x="-8630" y="9294"/>
+            <a:ext cx="12199938" cy="186903"/>
+            <a:chOff x="-8630" y="9294"/>
+            <a:chExt cx="12199938" cy="186903"/>
+          </a:xfrm>
+        </p:grpSpPr>
+        <p:pic>
+          <p:nvPicPr>
+            <p:cNvPr id="27" name="Image 39">
+              <a:extLst>
+                <a:ext uri="{FF2B5EF4-FFF2-40B4-BE49-F238E27FC236}">
+                  <a16:creationId xmlns:a16="http://schemas.microsoft.com/office/drawing/2014/main" id="{23DB73BA-95A0-15A7-07CB-46F7654FE6F5}"/>
+                </a:ext>
+              </a:extLst>
+            </p:cNvPr>
+            <p:cNvPicPr>
+              <a:picLocks noChangeAspect="1"/>
+            </p:cNvPicPr>
+            <p:nvPr/>
+          </p:nvPicPr>
+          <p:blipFill rotWithShape="1">
+            <a:blip r:embed="rId3" cstate="print">
+              <a:extLst>
+                <a:ext uri="{28A0092B-C50C-407E-A947-70E740481C1C}">
+                  <a14:useLocalDpi xmlns:a14="http://schemas.microsoft.com/office/drawing/2010/main" val="0"/>
+                </a:ext>
+              </a:extLst>
+            </a:blip>
+            <a:srcRect t="398"/>
+            <a:stretch/>
+          </p:blipFill>
+          <p:spPr bwMode="auto">
+            <a:xfrm rot="16200000" flipH="1">
+              <a:off x="3083618" y="-3082954"/>
+              <a:ext cx="184760" cy="6369256"/>
+            </a:xfrm>
+            <a:prstGeom prst="rect">
+              <a:avLst/>
+            </a:prstGeom>
+            <a:noFill/>
+            <a:ln>
+              <a:noFill/>
+            </a:ln>
+          </p:spPr>
+        </p:pic>
+        <p:pic>
+          <p:nvPicPr>
+            <p:cNvPr id="28" name="Image 39">
+              <a:extLst>
+                <a:ext uri="{FF2B5EF4-FFF2-40B4-BE49-F238E27FC236}">
+                  <a16:creationId xmlns:a16="http://schemas.microsoft.com/office/drawing/2014/main" id="{246EA41C-70C3-9776-2AAA-409AD6872778}"/>
+                </a:ext>
+              </a:extLst>
+            </p:cNvPr>
+            <p:cNvPicPr>
+              <a:picLocks noChangeAspect="1"/>
+            </p:cNvPicPr>
+            <p:nvPr/>
+          </p:nvPicPr>
+          <p:blipFill rotWithShape="1">
+            <a:blip r:embed="rId3" cstate="print">
+              <a:extLst>
+                <a:ext uri="{28A0092B-C50C-407E-A947-70E740481C1C}">
+                  <a14:useLocalDpi xmlns:a14="http://schemas.microsoft.com/office/drawing/2010/main" val="0"/>
+                </a:ext>
+              </a:extLst>
+            </a:blip>
+            <a:srcRect t="398"/>
+            <a:stretch/>
+          </p:blipFill>
+          <p:spPr bwMode="auto">
+            <a:xfrm rot="16200000" flipH="1">
+              <a:off x="8914300" y="-3080811"/>
+              <a:ext cx="184760" cy="6369256"/>
+            </a:xfrm>
+            <a:prstGeom prst="rect">
+              <a:avLst/>
+            </a:prstGeom>
+            <a:noFill/>
+            <a:ln>
+              <a:noFill/>
+            </a:ln>
+          </p:spPr>
+        </p:pic>
+      </p:grpSp>
     </p:spTree>
   </p:cSld>
   <p:clrMapOvr>

</xml_diff>